<commit_message>
Update department to Electronics and Telecommunication Engineering and remove obsolete files
</commit_message>
<xml_diff>
--- a/Ohms_Law_Presentation.pptx
+++ b/Ohms_Law_Presentation.pptx
@@ -3251,7 +3251,7 @@
               </a:defRPr>
             </a:pPr>
             <a:r>
-              <a:t>Department of Electrical Engineering</a:t>
+              <a:t>Department of Electronics and Telecommunication Engineering</a:t>
             </a:r>
           </a:p>
         </p:txBody>
@@ -4349,7 +4349,7 @@
               </a:defRPr>
             </a:pPr>
             <a:r>
-              <a:t>MIT Polytechnic &amp; Engineering, Yeola • Electrical Engineering</a:t>
+              <a:t>MIT Polytechnic &amp; Engineering, Yeola • Electronics and Telecommunication Engineering</a:t>
             </a:r>
           </a:p>
         </p:txBody>
@@ -4493,7 +4493,7 @@
               </a:defRPr>
             </a:pPr>
             <a:r>
-              <a:t>Ohm's Law is the most fundamental relationship in electrical engineering. Discovered by Georg Simon Ohm in 1827, it describes how voltage, current, and resistance are interrelated in an electrical circuit.</a:t>
+              <a:t>Ohm's Law is the most fundamental relationship in electronics and telecommunication engineering. Discovered by Georg Simon Ohm in 1827, it describes how voltage, current, and resistance are interrelated in an electrical circuit.</a:t>
             </a:r>
           </a:p>
           <a:p>

</xml_diff>